<commit_message>
Slide 5 redesign: show actual sampling distributions for the three methods
Previous version had three identical-looking Gaussians (all centered at 0
with a vertical line annotation) — visually unclear that the methods
differ. New version shows the actual sampling distribution each method
uses, with different μ at clearly different positions:

  - Vanilla MPPI        N(0, σ²I)            μ=0
  - Warm-start MPPI     N(μ_prev, σ²I)       μ=1.0
  - Demo / policy prior N(μ_p, σ²I)          μ=-1.6 (PiJEPA, VLMPC)

Same σ across all three (drives home: σ is always MPPI's default;
σ_p is discarded even when the prior provides it).

Bullets now give the formal one-line definition of each method instead
of vague "limitation" prose. Caption highlights that the three differ
only in WHERE μ is placed.

x-axis ticks removed (the "0" was overlapping the "uses:" caption text).

Co-Authored-By: Claude Opus 4.7 (1M context) <noreply@anthropic.com>
</commit_message>
<xml_diff>
--- a/prism_jepa_slides.pptx
+++ b/prism_jepa_slides.pptx
@@ -12079,8 +12079,8 @@
         </p:blipFill>
         <p:spPr>
           <a:xfrm>
-            <a:off x="457200" y="1188720"/>
-            <a:ext cx="11247120" cy="3657600"/>
+            <a:off x="274320" y="1097280"/>
+            <a:ext cx="11612880" cy="3383280"/>
           </a:xfrm>
           <a:prstGeom prst="rect">
             <a:avLst/>
@@ -12095,7 +12095,7 @@
         </p:nvSpPr>
         <p:spPr>
           <a:xfrm>
-            <a:off x="457200" y="5029200"/>
+            <a:off x="457200" y="4663440"/>
             <a:ext cx="11338560" cy="5120640"/>
           </a:xfrm>
           <a:prstGeom prst="rect">
@@ -12115,45 +12115,61 @@
               </a:spcAft>
             </a:pPr>
             <a:r>
-              <a:rPr sz="1600">
-                <a:solidFill>
-                  <a:srgbClr val="222222"/>
-                </a:solidFill>
-                <a:latin typeface="Calibri"/>
-              </a:rPr>
-              <a:t>• All three approaches share one limitation:</a:t>
-            </a:r>
-          </a:p>
-          <a:p>
-            <a:pPr lvl="1">
-              <a:spcAft>
-                <a:spcPts val="600"/>
-              </a:spcAft>
-            </a:pPr>
-            <a:r>
               <a:rPr sz="1400">
                 <a:solidFill>
-                  <a:srgbClr val="777777"/>
-                </a:solidFill>
-                <a:latin typeface="Calibri"/>
-              </a:rPr>
-              <a:t>▸ they replace only the mean — and discard how confident the demonstration is at this state.</a:t>
-            </a:r>
-          </a:p>
-          <a:p>
-            <a:pPr>
-              <a:spcAft>
-                <a:spcPts val="600"/>
-              </a:spcAft>
-            </a:pPr>
-            <a:r>
-              <a:rPr sz="1600">
-                <a:solidFill>
-                  <a:srgbClr val="222222"/>
-                </a:solidFill>
-                <a:latin typeface="Calibri"/>
-              </a:rPr>
-              <a:t>• But that confidence is exactly what matters for a sampling distribution.</a:t>
+                  <a:srgbClr val="222222"/>
+                </a:solidFill>
+                <a:latin typeface="Calibri"/>
+              </a:rPr>
+              <a:t>• Vanilla MPPI: sample from N(0, σ²I).  Zero-mean default — no demo info, no warm-start.</a:t>
+            </a:r>
+          </a:p>
+          <a:p>
+            <a:pPr>
+              <a:spcAft>
+                <a:spcPts val="600"/>
+              </a:spcAft>
+            </a:pPr>
+            <a:r>
+              <a:rPr sz="1400">
+                <a:solidFill>
+                  <a:srgbClr val="222222"/>
+                </a:solidFill>
+                <a:latin typeface="Calibri"/>
+              </a:rPr>
+              <a:t>• Warm-start MPPI: sample from N(μ_prev, σ²I).  μ_prev = previous step's planner solution rolled forward.</a:t>
+            </a:r>
+          </a:p>
+          <a:p>
+            <a:pPr>
+              <a:spcAft>
+                <a:spcPts val="600"/>
+              </a:spcAft>
+            </a:pPr>
+            <a:r>
+              <a:rPr sz="1400">
+                <a:solidFill>
+                  <a:srgbClr val="222222"/>
+                </a:solidFill>
+                <a:latin typeface="Calibri"/>
+              </a:rPr>
+              <a:t>• Demo / policy prior (PiJEPA, VLMPC): sample from N(μ_p, σ²I).  μ_p from a learned prior;  σ_p IS DISCARDED.</a:t>
+            </a:r>
+          </a:p>
+          <a:p>
+            <a:pPr>
+              <a:spcAft>
+                <a:spcPts val="600"/>
+              </a:spcAft>
+            </a:pPr>
+            <a:r>
+              <a:rPr sz="1400">
+                <a:solidFill>
+                  <a:srgbClr val="222222"/>
+                </a:solidFill>
+                <a:latin typeface="Calibri"/>
+              </a:rPr>
+              <a:t>• → Differ only in WHERE μ is placed.  σ is always the planner's fixed default.</a:t>
             </a:r>
           </a:p>
         </p:txBody>

</xml_diff>